<commit_message>
page2 = original centered design
</commit_message>
<xml_diff>
--- a/nif_banners.pptx
+++ b/nif_banners.pptx
@@ -4404,9 +4404,273 @@
           </a:p>
         </p:txBody>
       </p:sp>
+      <p:sp>
+        <p:nvSpPr>
+          <p:cNvPr id="3" name="Oval 2"/>
+          <p:cNvSpPr/>
+          <p:nvPr/>
+        </p:nvSpPr>
+        <p:spPr>
+          <a:xfrm>
+            <a:off x="-2476500" y="7810500"/>
+            <a:ext cx="4953000" cy="4953000"/>
+          </a:xfrm>
+          <a:prstGeom prst="ellipse">
+            <a:avLst/>
+          </a:prstGeom>
+          <a:noFill/>
+          <a:ln w="9525">
+            <a:solidFill>
+              <a:srgbClr val="A6852E"/>
+            </a:solidFill>
+          </a:ln>
+          <a:effectLst/>
+        </p:spPr>
+        <p:style>
+          <a:lnRef idx="1">
+            <a:schemeClr val="accent1"/>
+          </a:lnRef>
+          <a:fillRef idx="3">
+            <a:schemeClr val="accent1"/>
+          </a:fillRef>
+          <a:effectRef idx="2">
+            <a:schemeClr val="accent1"/>
+          </a:effectRef>
+          <a:fontRef idx="minor">
+            <a:schemeClr val="lt1"/>
+          </a:fontRef>
+        </p:style>
+        <p:txBody>
+          <a:bodyPr rtlCol="0" anchor="ctr"/>
+          <a:lstStyle/>
+          <a:p>
+            <a:pPr algn="ctr"/>
+          </a:p>
+        </p:txBody>
+      </p:sp>
+      <p:sp>
+        <p:nvSpPr>
+          <p:cNvPr id="4" name="Oval 3"/>
+          <p:cNvSpPr/>
+          <p:nvPr/>
+        </p:nvSpPr>
+        <p:spPr>
+          <a:xfrm>
+            <a:off x="-1809750" y="8477250"/>
+            <a:ext cx="3619500" cy="3619500"/>
+          </a:xfrm>
+          <a:prstGeom prst="ellipse">
+            <a:avLst/>
+          </a:prstGeom>
+          <a:noFill/>
+          <a:ln w="9525">
+            <a:solidFill>
+              <a:srgbClr val="A6852E"/>
+            </a:solidFill>
+          </a:ln>
+          <a:effectLst/>
+        </p:spPr>
+        <p:style>
+          <a:lnRef idx="1">
+            <a:schemeClr val="accent1"/>
+          </a:lnRef>
+          <a:fillRef idx="3">
+            <a:schemeClr val="accent1"/>
+          </a:fillRef>
+          <a:effectRef idx="2">
+            <a:schemeClr val="accent1"/>
+          </a:effectRef>
+          <a:fontRef idx="minor">
+            <a:schemeClr val="lt1"/>
+          </a:fontRef>
+        </p:style>
+        <p:txBody>
+          <a:bodyPr rtlCol="0" anchor="ctr"/>
+          <a:lstStyle/>
+          <a:p>
+            <a:pPr algn="ctr"/>
+          </a:p>
+        </p:txBody>
+      </p:sp>
+      <p:sp>
+        <p:nvSpPr>
+          <p:cNvPr id="5" name="Oval 4"/>
+          <p:cNvSpPr/>
+          <p:nvPr/>
+        </p:nvSpPr>
+        <p:spPr>
+          <a:xfrm>
+            <a:off x="-1143000" y="9144000"/>
+            <a:ext cx="2286000" cy="2286000"/>
+          </a:xfrm>
+          <a:prstGeom prst="ellipse">
+            <a:avLst/>
+          </a:prstGeom>
+          <a:noFill/>
+          <a:ln w="9525">
+            <a:solidFill>
+              <a:srgbClr val="A6852E"/>
+            </a:solidFill>
+          </a:ln>
+          <a:effectLst/>
+        </p:spPr>
+        <p:style>
+          <a:lnRef idx="1">
+            <a:schemeClr val="accent1"/>
+          </a:lnRef>
+          <a:fillRef idx="3">
+            <a:schemeClr val="accent1"/>
+          </a:fillRef>
+          <a:effectRef idx="2">
+            <a:schemeClr val="accent1"/>
+          </a:effectRef>
+          <a:fontRef idx="minor">
+            <a:schemeClr val="lt1"/>
+          </a:fontRef>
+        </p:style>
+        <p:txBody>
+          <a:bodyPr rtlCol="0" anchor="ctr"/>
+          <a:lstStyle/>
+          <a:p>
+            <a:pPr algn="ctr"/>
+          </a:p>
+        </p:txBody>
+      </p:sp>
+      <p:sp>
+        <p:nvSpPr>
+          <p:cNvPr id="6" name="Rectangle 5"/>
+          <p:cNvSpPr/>
+          <p:nvPr/>
+        </p:nvSpPr>
+        <p:spPr>
+          <a:xfrm>
+            <a:off x="0" y="0"/>
+            <a:ext cx="10287000" cy="1428750"/>
+          </a:xfrm>
+          <a:prstGeom prst="rect">
+            <a:avLst/>
+          </a:prstGeom>
+          <a:solidFill>
+            <a:srgbClr val="16244A"/>
+          </a:solidFill>
+          <a:ln>
+            <a:noFill/>
+          </a:ln>
+          <a:effectLst/>
+        </p:spPr>
+        <p:style>
+          <a:lnRef idx="1">
+            <a:schemeClr val="accent1"/>
+          </a:lnRef>
+          <a:fillRef idx="3">
+            <a:schemeClr val="accent1"/>
+          </a:fillRef>
+          <a:effectRef idx="2">
+            <a:schemeClr val="accent1"/>
+          </a:effectRef>
+          <a:fontRef idx="minor">
+            <a:schemeClr val="lt1"/>
+          </a:fontRef>
+        </p:style>
+        <p:txBody>
+          <a:bodyPr rtlCol="0" anchor="ctr"/>
+          <a:lstStyle/>
+          <a:p>
+            <a:pPr algn="ctr"/>
+          </a:p>
+        </p:txBody>
+      </p:sp>
+      <p:sp>
+        <p:nvSpPr>
+          <p:cNvPr id="7" name="Rectangle 6"/>
+          <p:cNvSpPr/>
+          <p:nvPr/>
+        </p:nvSpPr>
+        <p:spPr>
+          <a:xfrm>
+            <a:off x="0" y="1428750"/>
+            <a:ext cx="10287000" cy="57150"/>
+          </a:xfrm>
+          <a:prstGeom prst="rect">
+            <a:avLst/>
+          </a:prstGeom>
+          <a:solidFill>
+            <a:srgbClr val="A6852E"/>
+          </a:solidFill>
+          <a:ln>
+            <a:noFill/>
+          </a:ln>
+          <a:effectLst/>
+        </p:spPr>
+        <p:style>
+          <a:lnRef idx="1">
+            <a:schemeClr val="accent1"/>
+          </a:lnRef>
+          <a:fillRef idx="3">
+            <a:schemeClr val="accent1"/>
+          </a:fillRef>
+          <a:effectRef idx="2">
+            <a:schemeClr val="accent1"/>
+          </a:effectRef>
+          <a:fontRef idx="minor">
+            <a:schemeClr val="lt1"/>
+          </a:fontRef>
+        </p:style>
+        <p:txBody>
+          <a:bodyPr rtlCol="0" anchor="ctr"/>
+          <a:lstStyle/>
+          <a:p>
+            <a:pPr algn="ctr"/>
+          </a:p>
+        </p:txBody>
+      </p:sp>
+      <p:sp>
+        <p:nvSpPr>
+          <p:cNvPr id="8" name="Rounded Rectangle 7"/>
+          <p:cNvSpPr/>
+          <p:nvPr/>
+        </p:nvSpPr>
+        <p:spPr>
+          <a:xfrm>
+            <a:off x="381000" y="361950"/>
+            <a:ext cx="2190750" cy="704850"/>
+          </a:xfrm>
+          <a:prstGeom prst="roundRect">
+            <a:avLst/>
+          </a:prstGeom>
+          <a:solidFill>
+            <a:srgbClr val="F2F3F5"/>
+          </a:solidFill>
+          <a:ln>
+            <a:noFill/>
+          </a:ln>
+          <a:effectLst/>
+        </p:spPr>
+        <p:style>
+          <a:lnRef idx="1">
+            <a:schemeClr val="accent1"/>
+          </a:lnRef>
+          <a:fillRef idx="3">
+            <a:schemeClr val="accent1"/>
+          </a:fillRef>
+          <a:effectRef idx="2">
+            <a:schemeClr val="accent1"/>
+          </a:effectRef>
+          <a:fontRef idx="minor">
+            <a:schemeClr val="lt1"/>
+          </a:fontRef>
+        </p:style>
+        <p:txBody>
+          <a:bodyPr rtlCol="0" anchor="ctr"/>
+          <a:lstStyle/>
+          <a:p>
+            <a:pPr algn="ctr"/>
+          </a:p>
+        </p:txBody>
+      </p:sp>
       <p:pic>
         <p:nvPicPr>
-          <p:cNvPr id="3" name="Picture 2" descr="aastu.png"/>
+          <p:cNvPr id="9" name="Picture 8" descr="aastu.png"/>
           <p:cNvPicPr>
             <a:picLocks noChangeAspect="1"/>
           </p:cNvPicPr>
@@ -4420,7 +4684,7 @@
         </p:blipFill>
         <p:spPr>
           <a:xfrm>
-            <a:off x="571500" y="247650"/>
+            <a:off x="695325" y="495300"/>
             <a:ext cx="1553441" cy="438150"/>
           </a:xfrm>
           <a:prstGeom prst="rect">
@@ -4428,9 +4692,53 @@
           </a:prstGeom>
         </p:spPr>
       </p:pic>
+      <p:sp>
+        <p:nvSpPr>
+          <p:cNvPr id="10" name="Rounded Rectangle 9"/>
+          <p:cNvSpPr/>
+          <p:nvPr/>
+        </p:nvSpPr>
+        <p:spPr>
+          <a:xfrm>
+            <a:off x="7715250" y="361950"/>
+            <a:ext cx="2190750" cy="704850"/>
+          </a:xfrm>
+          <a:prstGeom prst="roundRect">
+            <a:avLst/>
+          </a:prstGeom>
+          <a:solidFill>
+            <a:srgbClr val="F2F3F5"/>
+          </a:solidFill>
+          <a:ln>
+            <a:noFill/>
+          </a:ln>
+          <a:effectLst/>
+        </p:spPr>
+        <p:style>
+          <a:lnRef idx="1">
+            <a:schemeClr val="accent1"/>
+          </a:lnRef>
+          <a:fillRef idx="3">
+            <a:schemeClr val="accent1"/>
+          </a:fillRef>
+          <a:effectRef idx="2">
+            <a:schemeClr val="accent1"/>
+          </a:effectRef>
+          <a:fontRef idx="minor">
+            <a:schemeClr val="lt1"/>
+          </a:fontRef>
+        </p:style>
+        <p:txBody>
+          <a:bodyPr rtlCol="0" anchor="ctr"/>
+          <a:lstStyle/>
+          <a:p>
+            <a:pPr algn="ctr"/>
+          </a:p>
+        </p:txBody>
+      </p:sp>
       <p:pic>
         <p:nvPicPr>
-          <p:cNvPr id="4" name="Picture 3" descr="edi.png"/>
+          <p:cNvPr id="11" name="Picture 10" descr="edi.png"/>
           <p:cNvPicPr>
             <a:picLocks noChangeAspect="1"/>
           </p:cNvPicPr>
@@ -4444,8 +4752,8 @@
         </p:blipFill>
         <p:spPr>
           <a:xfrm>
-            <a:off x="8139063" y="285750"/>
-            <a:ext cx="1576437" cy="361950"/>
+            <a:off x="7934325" y="504825"/>
+            <a:ext cx="1742378" cy="400050"/>
           </a:xfrm>
           <a:prstGeom prst="rect">
             <a:avLst/>
@@ -4454,14 +4762,14 @@
       </p:pic>
       <p:sp>
         <p:nvSpPr>
-          <p:cNvPr id="5" name="TextBox 4"/>
+          <p:cNvPr id="12" name="TextBox 11"/>
           <p:cNvSpPr txBox="1"/>
           <p:nvPr/>
         </p:nvSpPr>
         <p:spPr>
           <a:xfrm>
-            <a:off x="3429000" y="285750"/>
-            <a:ext cx="3429000" cy="419100"/>
+            <a:off x="2667000" y="381000"/>
+            <a:ext cx="4953000" cy="666750"/>
           </a:xfrm>
           <a:prstGeom prst="rect">
             <a:avLst/>
@@ -4476,13 +4784,13 @@
           <a:p>
             <a:pPr algn="ctr">
               <a:lnSpc>
-                <a:spcPct val="112000"/>
+                <a:spcPct val="110000"/>
               </a:lnSpc>
             </a:pPr>
             <a:r>
-              <a:rPr sz="1050" b="1" i="0">
-                <a:solidFill>
-                  <a:srgbClr val="1B2642"/>
+              <a:rPr sz="1300" b="1" i="0">
+                <a:solidFill>
+                  <a:srgbClr val="FFFFFF"/>
                 </a:solidFill>
                 <a:latin typeface="Arial"/>
               </a:rPr>
@@ -4492,13 +4800,13 @@
           <a:p>
             <a:pPr algn="ctr">
               <a:lnSpc>
-                <a:spcPct val="112000"/>
+                <a:spcPct val="110000"/>
               </a:lnSpc>
             </a:pPr>
             <a:r>
-              <a:rPr sz="1000" b="1" i="0">
-                <a:solidFill>
-                  <a:srgbClr val="C29A3A"/>
+              <a:rPr sz="1200" b="1" i="0">
+                <a:solidFill>
+                  <a:srgbClr val="A6852E"/>
                 </a:solidFill>
                 <a:latin typeface="Arial"/>
               </a:rPr>
@@ -4509,20 +4817,20 @@
       </p:sp>
       <p:sp>
         <p:nvSpPr>
-          <p:cNvPr id="6" name="Rectangle 5"/>
+          <p:cNvPr id="13" name="Rounded Rectangle 12"/>
           <p:cNvSpPr/>
           <p:nvPr/>
         </p:nvSpPr>
         <p:spPr>
           <a:xfrm>
-            <a:off x="0" y="914400"/>
-            <a:ext cx="10287000" cy="28575"/>
-          </a:xfrm>
-          <a:prstGeom prst="rect">
+            <a:off x="2762250" y="1885950"/>
+            <a:ext cx="4762500" cy="476250"/>
+          </a:xfrm>
+          <a:prstGeom prst="roundRect">
             <a:avLst/>
           </a:prstGeom>
           <a:solidFill>
-            <a:srgbClr val="C29A3A"/>
+            <a:srgbClr val="16244A"/>
           </a:solidFill>
           <a:ln>
             <a:noFill/>
@@ -4553,20 +4861,716 @@
       </p:sp>
       <p:sp>
         <p:nvSpPr>
-          <p:cNvPr id="7" name="Rectangle 6"/>
+          <p:cNvPr id="14" name="TextBox 13"/>
+          <p:cNvSpPr txBox="1"/>
+          <p:nvPr/>
+        </p:nvSpPr>
+        <p:spPr>
+          <a:xfrm>
+            <a:off x="2762250" y="1885950"/>
+            <a:ext cx="4762500" cy="476250"/>
+          </a:xfrm>
+          <a:prstGeom prst="rect">
+            <a:avLst/>
+          </a:prstGeom>
+          <a:noFill/>
+        </p:spPr>
+        <p:txBody>
+          <a:bodyPr wrap="square" anchor="ctr" lIns="0" rIns="0" tIns="0" bIns="0">
+            <a:spAutoFit/>
+          </a:bodyPr>
+          <a:lstStyle/>
+          <a:p>
+            <a:pPr algn="ctr"/>
+            <a:r>
+              <a:rPr sz="1400" b="1" i="0">
+                <a:solidFill>
+                  <a:srgbClr val="FFFFFF"/>
+                </a:solidFill>
+                <a:latin typeface="Arial"/>
+              </a:rPr>
+              <a:t>DAY 1  ·  JUNE 23, 2026  ·  08:30 – 10:30</a:t>
+            </a:r>
+          </a:p>
+        </p:txBody>
+      </p:sp>
+      <p:sp>
+        <p:nvSpPr>
+          <p:cNvPr id="15" name="TextBox 14"/>
+          <p:cNvSpPr txBox="1"/>
+          <p:nvPr/>
+        </p:nvSpPr>
+        <p:spPr>
+          <a:xfrm>
+            <a:off x="857250" y="2552700"/>
+            <a:ext cx="8572500" cy="323850"/>
+          </a:xfrm>
+          <a:prstGeom prst="rect">
+            <a:avLst/>
+          </a:prstGeom>
+          <a:noFill/>
+        </p:spPr>
+        <p:txBody>
+          <a:bodyPr wrap="square" anchor="t" lIns="0" rIns="0" tIns="0" bIns="0">
+            <a:spAutoFit/>
+          </a:bodyPr>
+          <a:lstStyle/>
+          <a:p>
+            <a:pPr algn="ctr"/>
+            <a:r>
+              <a:rPr sz="1500" b="1" i="0">
+                <a:solidFill>
+                  <a:srgbClr val="A6852E"/>
+                </a:solidFill>
+                <a:latin typeface="Arial"/>
+              </a:rPr>
+              <a:t>OPENING SESSION</a:t>
+            </a:r>
+          </a:p>
+        </p:txBody>
+      </p:sp>
+      <p:sp>
+        <p:nvSpPr>
+          <p:cNvPr id="16" name="TextBox 15"/>
+          <p:cNvSpPr txBox="1"/>
+          <p:nvPr/>
+        </p:nvSpPr>
+        <p:spPr>
+          <a:xfrm>
+            <a:off x="666750" y="2971800"/>
+            <a:ext cx="8953500" cy="1428750"/>
+          </a:xfrm>
+          <a:prstGeom prst="rect">
+            <a:avLst/>
+          </a:prstGeom>
+          <a:noFill/>
+        </p:spPr>
+        <p:txBody>
+          <a:bodyPr wrap="square" anchor="ctr" lIns="0" rIns="0" tIns="0" bIns="0">
+            <a:spAutoFit/>
+          </a:bodyPr>
+          <a:lstStyle/>
+          <a:p>
+            <a:pPr algn="ctr">
+              <a:lnSpc>
+                <a:spcPct val="100000"/>
+              </a:lnSpc>
+            </a:pPr>
+            <a:r>
+              <a:rPr sz="4400" b="1" i="0">
+                <a:solidFill>
+                  <a:srgbClr val="16244A"/>
+                </a:solidFill>
+                <a:latin typeface="Arial"/>
+              </a:rPr>
+              <a:t>Opening Plenary &amp; Ministerial Keynote</a:t>
+            </a:r>
+          </a:p>
+        </p:txBody>
+      </p:sp>
+      <p:sp>
+        <p:nvSpPr>
+          <p:cNvPr id="17" name="TextBox 16"/>
+          <p:cNvSpPr txBox="1"/>
+          <p:nvPr/>
+        </p:nvSpPr>
+        <p:spPr>
+          <a:xfrm>
+            <a:off x="1143000" y="4476750"/>
+            <a:ext cx="8001000" cy="762000"/>
+          </a:xfrm>
+          <a:prstGeom prst="rect">
+            <a:avLst/>
+          </a:prstGeom>
+          <a:noFill/>
+        </p:spPr>
+        <p:txBody>
+          <a:bodyPr wrap="square" anchor="ctr" lIns="0" rIns="0" tIns="0" bIns="0">
+            <a:spAutoFit/>
+          </a:bodyPr>
+          <a:lstStyle/>
+          <a:p>
+            <a:pPr algn="ctr">
+              <a:lnSpc>
+                <a:spcPct val="105000"/>
+              </a:lnSpc>
+            </a:pPr>
+            <a:r>
+              <a:rPr sz="2100" b="0" i="1">
+                <a:solidFill>
+                  <a:srgbClr val="A6852E"/>
+                </a:solidFill>
+                <a:latin typeface="Arial"/>
+              </a:rPr>
+              <a:t>“The National Innovation Ecosystem in Ethiopia: Gaps &amp; Horizons”</a:t>
+            </a:r>
+          </a:p>
+        </p:txBody>
+      </p:sp>
+      <p:sp>
+        <p:nvSpPr>
+          <p:cNvPr id="18" name="Oval 17"/>
           <p:cNvSpPr/>
           <p:nvPr/>
         </p:nvSpPr>
         <p:spPr>
           <a:xfrm>
-            <a:off x="0" y="942975"/>
-            <a:ext cx="4191000" cy="9344025"/>
-          </a:xfrm>
-          <a:prstGeom prst="rect">
+            <a:off x="857250" y="5619750"/>
+            <a:ext cx="1428750" cy="1428750"/>
+          </a:xfrm>
+          <a:prstGeom prst="ellipse">
             <a:avLst/>
           </a:prstGeom>
           <a:solidFill>
-            <a:srgbClr val="142145"/>
+            <a:srgbClr val="F2F3F5"/>
+          </a:solidFill>
+          <a:ln w="15875">
+            <a:solidFill>
+              <a:srgbClr val="16244A"/>
+            </a:solidFill>
+            <a:prstDash val="dash"/>
+          </a:ln>
+          <a:effectLst/>
+        </p:spPr>
+        <p:style>
+          <a:lnRef idx="1">
+            <a:schemeClr val="accent1"/>
+          </a:lnRef>
+          <a:fillRef idx="3">
+            <a:schemeClr val="accent1"/>
+          </a:fillRef>
+          <a:effectRef idx="2">
+            <a:schemeClr val="accent1"/>
+          </a:effectRef>
+          <a:fontRef idx="minor">
+            <a:schemeClr val="lt1"/>
+          </a:fontRef>
+        </p:style>
+        <p:txBody>
+          <a:bodyPr rtlCol="0" anchor="ctr"/>
+          <a:lstStyle/>
+          <a:p>
+            <a:pPr algn="ctr"/>
+          </a:p>
+        </p:txBody>
+      </p:sp>
+      <p:sp>
+        <p:nvSpPr>
+          <p:cNvPr id="19" name="TextBox 18"/>
+          <p:cNvSpPr txBox="1"/>
+          <p:nvPr/>
+        </p:nvSpPr>
+        <p:spPr>
+          <a:xfrm>
+            <a:off x="857250" y="5619750"/>
+            <a:ext cx="1428750" cy="1428750"/>
+          </a:xfrm>
+          <a:prstGeom prst="rect">
+            <a:avLst/>
+          </a:prstGeom>
+          <a:noFill/>
+        </p:spPr>
+        <p:txBody>
+          <a:bodyPr wrap="square" anchor="ctr" lIns="0" rIns="0" tIns="0" bIns="0">
+            <a:spAutoFit/>
+          </a:bodyPr>
+          <a:lstStyle/>
+          <a:p>
+            <a:pPr algn="ctr"/>
+            <a:r>
+              <a:rPr sz="1100" b="0" i="0">
+                <a:solidFill>
+                  <a:srgbClr val="8A909C"/>
+                </a:solidFill>
+                <a:latin typeface="Arial"/>
+              </a:rPr>
+              <a:t>PHOTO</a:t>
+            </a:r>
+          </a:p>
+        </p:txBody>
+      </p:sp>
+      <p:sp>
+        <p:nvSpPr>
+          <p:cNvPr id="20" name="TextBox 19"/>
+          <p:cNvSpPr txBox="1"/>
+          <p:nvPr/>
+        </p:nvSpPr>
+        <p:spPr>
+          <a:xfrm>
+            <a:off x="476250" y="7162800"/>
+            <a:ext cx="2190750" cy="571500"/>
+          </a:xfrm>
+          <a:prstGeom prst="rect">
+            <a:avLst/>
+          </a:prstGeom>
+          <a:noFill/>
+        </p:spPr>
+        <p:txBody>
+          <a:bodyPr wrap="square" anchor="t" lIns="0" rIns="0" tIns="0" bIns="0">
+            <a:spAutoFit/>
+          </a:bodyPr>
+          <a:lstStyle/>
+          <a:p>
+            <a:pPr algn="ctr">
+              <a:lnSpc>
+                <a:spcPct val="110000"/>
+              </a:lnSpc>
+            </a:pPr>
+            <a:r>
+              <a:rPr sz="1350" b="1" i="0">
+                <a:solidFill>
+                  <a:srgbClr val="16244A"/>
+                </a:solidFill>
+                <a:latin typeface="Arial"/>
+              </a:rPr>
+              <a:t>H.E. Muferiat Kamil</a:t>
+            </a:r>
+          </a:p>
+          <a:p>
+            <a:pPr algn="ctr">
+              <a:lnSpc>
+                <a:spcPct val="110000"/>
+              </a:lnSpc>
+            </a:pPr>
+            <a:r>
+              <a:rPr sz="1100" b="0" i="0">
+                <a:solidFill>
+                  <a:srgbClr val="A6852E"/>
+                </a:solidFill>
+                <a:latin typeface="Arial"/>
+              </a:rPr>
+              <a:t>Minister, MInT</a:t>
+            </a:r>
+          </a:p>
+        </p:txBody>
+      </p:sp>
+      <p:sp>
+        <p:nvSpPr>
+          <p:cNvPr id="21" name="Oval 20"/>
+          <p:cNvSpPr/>
+          <p:nvPr/>
+        </p:nvSpPr>
+        <p:spPr>
+          <a:xfrm>
+            <a:off x="3238500" y="5619750"/>
+            <a:ext cx="1428750" cy="1428750"/>
+          </a:xfrm>
+          <a:prstGeom prst="ellipse">
+            <a:avLst/>
+          </a:prstGeom>
+          <a:solidFill>
+            <a:srgbClr val="F2F3F5"/>
+          </a:solidFill>
+          <a:ln w="15875">
+            <a:solidFill>
+              <a:srgbClr val="16244A"/>
+            </a:solidFill>
+            <a:prstDash val="dash"/>
+          </a:ln>
+          <a:effectLst/>
+        </p:spPr>
+        <p:style>
+          <a:lnRef idx="1">
+            <a:schemeClr val="accent1"/>
+          </a:lnRef>
+          <a:fillRef idx="3">
+            <a:schemeClr val="accent1"/>
+          </a:fillRef>
+          <a:effectRef idx="2">
+            <a:schemeClr val="accent1"/>
+          </a:effectRef>
+          <a:fontRef idx="minor">
+            <a:schemeClr val="lt1"/>
+          </a:fontRef>
+        </p:style>
+        <p:txBody>
+          <a:bodyPr rtlCol="0" anchor="ctr"/>
+          <a:lstStyle/>
+          <a:p>
+            <a:pPr algn="ctr"/>
+          </a:p>
+        </p:txBody>
+      </p:sp>
+      <p:sp>
+        <p:nvSpPr>
+          <p:cNvPr id="22" name="TextBox 21"/>
+          <p:cNvSpPr txBox="1"/>
+          <p:nvPr/>
+        </p:nvSpPr>
+        <p:spPr>
+          <a:xfrm>
+            <a:off x="3238500" y="5619750"/>
+            <a:ext cx="1428750" cy="1428750"/>
+          </a:xfrm>
+          <a:prstGeom prst="rect">
+            <a:avLst/>
+          </a:prstGeom>
+          <a:noFill/>
+        </p:spPr>
+        <p:txBody>
+          <a:bodyPr wrap="square" anchor="ctr" lIns="0" rIns="0" tIns="0" bIns="0">
+            <a:spAutoFit/>
+          </a:bodyPr>
+          <a:lstStyle/>
+          <a:p>
+            <a:pPr algn="ctr"/>
+            <a:r>
+              <a:rPr sz="1100" b="0" i="0">
+                <a:solidFill>
+                  <a:srgbClr val="8A909C"/>
+                </a:solidFill>
+                <a:latin typeface="Arial"/>
+              </a:rPr>
+              <a:t>PHOTO</a:t>
+            </a:r>
+          </a:p>
+        </p:txBody>
+      </p:sp>
+      <p:sp>
+        <p:nvSpPr>
+          <p:cNvPr id="23" name="TextBox 22"/>
+          <p:cNvSpPr txBox="1"/>
+          <p:nvPr/>
+        </p:nvSpPr>
+        <p:spPr>
+          <a:xfrm>
+            <a:off x="2857500" y="7162800"/>
+            <a:ext cx="2190750" cy="571500"/>
+          </a:xfrm>
+          <a:prstGeom prst="rect">
+            <a:avLst/>
+          </a:prstGeom>
+          <a:noFill/>
+        </p:spPr>
+        <p:txBody>
+          <a:bodyPr wrap="square" anchor="t" lIns="0" rIns="0" tIns="0" bIns="0">
+            <a:spAutoFit/>
+          </a:bodyPr>
+          <a:lstStyle/>
+          <a:p>
+            <a:pPr algn="ctr">
+              <a:lnSpc>
+                <a:spcPct val="110000"/>
+              </a:lnSpc>
+            </a:pPr>
+            <a:r>
+              <a:rPr sz="1350" b="1" i="0">
+                <a:solidFill>
+                  <a:srgbClr val="16244A"/>
+                </a:solidFill>
+                <a:latin typeface="Arial"/>
+              </a:rPr>
+              <a:t>H.E. Belete Molla</a:t>
+            </a:r>
+          </a:p>
+          <a:p>
+            <a:pPr algn="ctr">
+              <a:lnSpc>
+                <a:spcPct val="110000"/>
+              </a:lnSpc>
+            </a:pPr>
+            <a:r>
+              <a:rPr sz="1100" b="0" i="0">
+                <a:solidFill>
+                  <a:srgbClr val="A6852E"/>
+                </a:solidFill>
+                <a:latin typeface="Arial"/>
+              </a:rPr>
+              <a:t>Minister of Industry</a:t>
+            </a:r>
+          </a:p>
+        </p:txBody>
+      </p:sp>
+      <p:sp>
+        <p:nvSpPr>
+          <p:cNvPr id="24" name="Oval 23"/>
+          <p:cNvSpPr/>
+          <p:nvPr/>
+        </p:nvSpPr>
+        <p:spPr>
+          <a:xfrm>
+            <a:off x="5619750" y="5619750"/>
+            <a:ext cx="1428750" cy="1428750"/>
+          </a:xfrm>
+          <a:prstGeom prst="ellipse">
+            <a:avLst/>
+          </a:prstGeom>
+          <a:solidFill>
+            <a:srgbClr val="F2F3F5"/>
+          </a:solidFill>
+          <a:ln w="15875">
+            <a:solidFill>
+              <a:srgbClr val="16244A"/>
+            </a:solidFill>
+            <a:prstDash val="dash"/>
+          </a:ln>
+          <a:effectLst/>
+        </p:spPr>
+        <p:style>
+          <a:lnRef idx="1">
+            <a:schemeClr val="accent1"/>
+          </a:lnRef>
+          <a:fillRef idx="3">
+            <a:schemeClr val="accent1"/>
+          </a:fillRef>
+          <a:effectRef idx="2">
+            <a:schemeClr val="accent1"/>
+          </a:effectRef>
+          <a:fontRef idx="minor">
+            <a:schemeClr val="lt1"/>
+          </a:fontRef>
+        </p:style>
+        <p:txBody>
+          <a:bodyPr rtlCol="0" anchor="ctr"/>
+          <a:lstStyle/>
+          <a:p>
+            <a:pPr algn="ctr"/>
+          </a:p>
+        </p:txBody>
+      </p:sp>
+      <p:sp>
+        <p:nvSpPr>
+          <p:cNvPr id="25" name="TextBox 24"/>
+          <p:cNvSpPr txBox="1"/>
+          <p:nvPr/>
+        </p:nvSpPr>
+        <p:spPr>
+          <a:xfrm>
+            <a:off x="5619750" y="5619750"/>
+            <a:ext cx="1428750" cy="1428750"/>
+          </a:xfrm>
+          <a:prstGeom prst="rect">
+            <a:avLst/>
+          </a:prstGeom>
+          <a:noFill/>
+        </p:spPr>
+        <p:txBody>
+          <a:bodyPr wrap="square" anchor="ctr" lIns="0" rIns="0" tIns="0" bIns="0">
+            <a:spAutoFit/>
+          </a:bodyPr>
+          <a:lstStyle/>
+          <a:p>
+            <a:pPr algn="ctr"/>
+            <a:r>
+              <a:rPr sz="1100" b="0" i="0">
+                <a:solidFill>
+                  <a:srgbClr val="8A909C"/>
+                </a:solidFill>
+                <a:latin typeface="Arial"/>
+              </a:rPr>
+              <a:t>PHOTO</a:t>
+            </a:r>
+          </a:p>
+        </p:txBody>
+      </p:sp>
+      <p:sp>
+        <p:nvSpPr>
+          <p:cNvPr id="26" name="TextBox 25"/>
+          <p:cNvSpPr txBox="1"/>
+          <p:nvPr/>
+        </p:nvSpPr>
+        <p:spPr>
+          <a:xfrm>
+            <a:off x="5238750" y="7162800"/>
+            <a:ext cx="2190750" cy="571500"/>
+          </a:xfrm>
+          <a:prstGeom prst="rect">
+            <a:avLst/>
+          </a:prstGeom>
+          <a:noFill/>
+        </p:spPr>
+        <p:txBody>
+          <a:bodyPr wrap="square" anchor="t" lIns="0" rIns="0" tIns="0" bIns="0">
+            <a:spAutoFit/>
+          </a:bodyPr>
+          <a:lstStyle/>
+          <a:p>
+            <a:pPr algn="ctr">
+              <a:lnSpc>
+                <a:spcPct val="110000"/>
+              </a:lnSpc>
+            </a:pPr>
+            <a:r>
+              <a:rPr sz="1350" b="1" i="0">
+                <a:solidFill>
+                  <a:srgbClr val="16244A"/>
+                </a:solidFill>
+                <a:latin typeface="Arial"/>
+              </a:rPr>
+              <a:t>Dr. Abreham Debebe</a:t>
+            </a:r>
+          </a:p>
+          <a:p>
+            <a:pPr algn="ctr">
+              <a:lnSpc>
+                <a:spcPct val="110000"/>
+              </a:lnSpc>
+            </a:pPr>
+            <a:r>
+              <a:rPr sz="1100" b="0" i="0">
+                <a:solidFill>
+                  <a:srgbClr val="A6852E"/>
+                </a:solidFill>
+                <a:latin typeface="Arial"/>
+              </a:rPr>
+              <a:t>AASTU</a:t>
+            </a:r>
+          </a:p>
+        </p:txBody>
+      </p:sp>
+      <p:sp>
+        <p:nvSpPr>
+          <p:cNvPr id="27" name="Oval 26"/>
+          <p:cNvSpPr/>
+          <p:nvPr/>
+        </p:nvSpPr>
+        <p:spPr>
+          <a:xfrm>
+            <a:off x="8001000" y="5619750"/>
+            <a:ext cx="1428750" cy="1428750"/>
+          </a:xfrm>
+          <a:prstGeom prst="ellipse">
+            <a:avLst/>
+          </a:prstGeom>
+          <a:solidFill>
+            <a:srgbClr val="F2F3F5"/>
+          </a:solidFill>
+          <a:ln w="15875">
+            <a:solidFill>
+              <a:srgbClr val="16244A"/>
+            </a:solidFill>
+            <a:prstDash val="dash"/>
+          </a:ln>
+          <a:effectLst/>
+        </p:spPr>
+        <p:style>
+          <a:lnRef idx="1">
+            <a:schemeClr val="accent1"/>
+          </a:lnRef>
+          <a:fillRef idx="3">
+            <a:schemeClr val="accent1"/>
+          </a:fillRef>
+          <a:effectRef idx="2">
+            <a:schemeClr val="accent1"/>
+          </a:effectRef>
+          <a:fontRef idx="minor">
+            <a:schemeClr val="lt1"/>
+          </a:fontRef>
+        </p:style>
+        <p:txBody>
+          <a:bodyPr rtlCol="0" anchor="ctr"/>
+          <a:lstStyle/>
+          <a:p>
+            <a:pPr algn="ctr"/>
+          </a:p>
+        </p:txBody>
+      </p:sp>
+      <p:sp>
+        <p:nvSpPr>
+          <p:cNvPr id="28" name="TextBox 27"/>
+          <p:cNvSpPr txBox="1"/>
+          <p:nvPr/>
+        </p:nvSpPr>
+        <p:spPr>
+          <a:xfrm>
+            <a:off x="8001000" y="5619750"/>
+            <a:ext cx="1428750" cy="1428750"/>
+          </a:xfrm>
+          <a:prstGeom prst="rect">
+            <a:avLst/>
+          </a:prstGeom>
+          <a:noFill/>
+        </p:spPr>
+        <p:txBody>
+          <a:bodyPr wrap="square" anchor="ctr" lIns="0" rIns="0" tIns="0" bIns="0">
+            <a:spAutoFit/>
+          </a:bodyPr>
+          <a:lstStyle/>
+          <a:p>
+            <a:pPr algn="ctr"/>
+            <a:r>
+              <a:rPr sz="1100" b="0" i="0">
+                <a:solidFill>
+                  <a:srgbClr val="8A909C"/>
+                </a:solidFill>
+                <a:latin typeface="Arial"/>
+              </a:rPr>
+              <a:t>PHOTO</a:t>
+            </a:r>
+          </a:p>
+        </p:txBody>
+      </p:sp>
+      <p:sp>
+        <p:nvSpPr>
+          <p:cNvPr id="29" name="TextBox 28"/>
+          <p:cNvSpPr txBox="1"/>
+          <p:nvPr/>
+        </p:nvSpPr>
+        <p:spPr>
+          <a:xfrm>
+            <a:off x="7620000" y="7162800"/>
+            <a:ext cx="2190750" cy="571500"/>
+          </a:xfrm>
+          <a:prstGeom prst="rect">
+            <a:avLst/>
+          </a:prstGeom>
+          <a:noFill/>
+        </p:spPr>
+        <p:txBody>
+          <a:bodyPr wrap="square" anchor="t" lIns="0" rIns="0" tIns="0" bIns="0">
+            <a:spAutoFit/>
+          </a:bodyPr>
+          <a:lstStyle/>
+          <a:p>
+            <a:pPr algn="ctr">
+              <a:lnSpc>
+                <a:spcPct val="110000"/>
+              </a:lnSpc>
+            </a:pPr>
+            <a:r>
+              <a:rPr sz="1350" b="1" i="0">
+                <a:solidFill>
+                  <a:srgbClr val="16244A"/>
+                </a:solidFill>
+                <a:latin typeface="Arial"/>
+              </a:rPr>
+              <a:t>Dr. Dereje Engida</a:t>
+            </a:r>
+          </a:p>
+          <a:p>
+            <a:pPr algn="ctr">
+              <a:lnSpc>
+                <a:spcPct val="110000"/>
+              </a:lnSpc>
+            </a:pPr>
+            <a:r>
+              <a:rPr sz="1100" b="0" i="0">
+                <a:solidFill>
+                  <a:srgbClr val="A6852E"/>
+                </a:solidFill>
+                <a:latin typeface="Arial"/>
+              </a:rPr>
+              <a:t>EDI</a:t>
+            </a:r>
+          </a:p>
+        </p:txBody>
+      </p:sp>
+      <p:sp>
+        <p:nvSpPr>
+          <p:cNvPr id="30" name="Rectangle 29"/>
+          <p:cNvSpPr/>
+          <p:nvPr/>
+        </p:nvSpPr>
+        <p:spPr>
+          <a:xfrm>
+            <a:off x="0" y="9334500"/>
+            <a:ext cx="10287000" cy="952500"/>
+          </a:xfrm>
+          <a:prstGeom prst="rect">
+            <a:avLst/>
+          </a:prstGeom>
+          <a:solidFill>
+            <a:srgbClr val="16244A"/>
           </a:solidFill>
           <a:ln>
             <a:noFill/>
@@ -4597,130 +5601,20 @@
       </p:sp>
       <p:sp>
         <p:nvSpPr>
-          <p:cNvPr id="8" name="TextBox 7"/>
-          <p:cNvSpPr txBox="1"/>
-          <p:nvPr/>
-        </p:nvSpPr>
-        <p:spPr>
-          <a:xfrm>
-            <a:off x="457200" y="1428750"/>
-            <a:ext cx="3429000" cy="209550"/>
-          </a:xfrm>
-          <a:prstGeom prst="rect">
-            <a:avLst/>
-          </a:prstGeom>
-          <a:noFill/>
-        </p:spPr>
-        <p:txBody>
-          <a:bodyPr wrap="square" anchor="t" lIns="0" rIns="0" tIns="0" bIns="0">
-            <a:spAutoFit/>
-          </a:bodyPr>
-          <a:lstStyle/>
-          <a:p>
-            <a:pPr algn="l"/>
-            <a:r>
-              <a:rPr sz="1250" b="1" i="0">
-                <a:solidFill>
-                  <a:srgbClr val="C29A3A"/>
-                </a:solidFill>
-                <a:latin typeface="Arial"/>
-              </a:rPr>
-              <a:t>OPENING SESSION</a:t>
-            </a:r>
-          </a:p>
-        </p:txBody>
-      </p:sp>
-      <p:sp>
-        <p:nvSpPr>
-          <p:cNvPr id="9" name="TextBox 8"/>
-          <p:cNvSpPr txBox="1"/>
-          <p:nvPr/>
-        </p:nvSpPr>
-        <p:spPr>
-          <a:xfrm>
-            <a:off x="457200" y="1676400"/>
-            <a:ext cx="3429000" cy="209550"/>
-          </a:xfrm>
-          <a:prstGeom prst="rect">
-            <a:avLst/>
-          </a:prstGeom>
-          <a:noFill/>
-        </p:spPr>
-        <p:txBody>
-          <a:bodyPr wrap="square" anchor="t" lIns="0" rIns="0" tIns="0" bIns="0">
-            <a:spAutoFit/>
-          </a:bodyPr>
-          <a:lstStyle/>
-          <a:p>
-            <a:pPr algn="l"/>
-            <a:r>
-              <a:rPr sz="1100" b="0" i="0">
-                <a:solidFill>
-                  <a:srgbClr val="C8CDD6"/>
-                </a:solidFill>
-                <a:latin typeface="Arial"/>
-              </a:rPr>
-              <a:t>DAY 1  ·  JUNE 23, 2026  ·  08:30 – 10:30</a:t>
-            </a:r>
-          </a:p>
-        </p:txBody>
-      </p:sp>
-      <p:sp>
-        <p:nvSpPr>
-          <p:cNvPr id="10" name="TextBox 9"/>
-          <p:cNvSpPr txBox="1"/>
-          <p:nvPr/>
-        </p:nvSpPr>
-        <p:spPr>
-          <a:xfrm>
-            <a:off x="457200" y="2114550"/>
-            <a:ext cx="3429000" cy="2095500"/>
-          </a:xfrm>
-          <a:prstGeom prst="rect">
-            <a:avLst/>
-          </a:prstGeom>
-          <a:noFill/>
-        </p:spPr>
-        <p:txBody>
-          <a:bodyPr wrap="square" anchor="t" lIns="0" rIns="0" tIns="0" bIns="0">
-            <a:spAutoFit/>
-          </a:bodyPr>
-          <a:lstStyle/>
-          <a:p>
-            <a:pPr algn="l">
-              <a:lnSpc>
-                <a:spcPct val="104000"/>
-              </a:lnSpc>
-            </a:pPr>
-            <a:r>
-              <a:rPr sz="3800" b="1" i="0">
-                <a:solidFill>
-                  <a:srgbClr val="FFFFFF"/>
-                </a:solidFill>
-                <a:latin typeface="Arial"/>
-              </a:rPr>
-              <a:t>Opening Plenary &amp;
-Ministerial Keynote</a:t>
-            </a:r>
-          </a:p>
-        </p:txBody>
-      </p:sp>
-      <p:sp>
-        <p:nvSpPr>
-          <p:cNvPr id="11" name="Rectangle 10"/>
+          <p:cNvPr id="31" name="Rectangle 30"/>
           <p:cNvSpPr/>
           <p:nvPr/>
         </p:nvSpPr>
         <p:spPr>
           <a:xfrm>
-            <a:off x="457200" y="4305300"/>
-            <a:ext cx="857250" cy="38100"/>
+            <a:off x="0" y="9277350"/>
+            <a:ext cx="10287000" cy="57150"/>
           </a:xfrm>
           <a:prstGeom prst="rect">
             <a:avLst/>
           </a:prstGeom>
           <a:solidFill>
-            <a:srgbClr val="C29A3A"/>
+            <a:srgbClr val="A6852E"/>
           </a:solidFill>
           <a:ln>
             <a:noFill/>
@@ -4751,327 +5645,14 @@
       </p:sp>
       <p:sp>
         <p:nvSpPr>
-          <p:cNvPr id="12" name="TextBox 11"/>
+          <p:cNvPr id="32" name="TextBox 31"/>
           <p:cNvSpPr txBox="1"/>
           <p:nvPr/>
         </p:nvSpPr>
         <p:spPr>
           <a:xfrm>
-            <a:off x="457200" y="4514850"/>
-            <a:ext cx="3333750" cy="1143000"/>
-          </a:xfrm>
-          <a:prstGeom prst="rect">
-            <a:avLst/>
-          </a:prstGeom>
-          <a:noFill/>
-        </p:spPr>
-        <p:txBody>
-          <a:bodyPr wrap="square" anchor="t" lIns="0" rIns="0" tIns="0" bIns="0">
-            <a:spAutoFit/>
-          </a:bodyPr>
-          <a:lstStyle/>
-          <a:p>
-            <a:pPr algn="l">
-              <a:lnSpc>
-                <a:spcPct val="115000"/>
-              </a:lnSpc>
-            </a:pPr>
-            <a:r>
-              <a:rPr sz="1550" b="0" i="1">
-                <a:solidFill>
-                  <a:srgbClr val="C8CDD6"/>
-                </a:solidFill>
-                <a:latin typeface="Arial"/>
-              </a:rPr>
-              <a:t>“The National Innovation Ecosystem in Ethiopia: Gaps &amp; Horizons”</a:t>
-            </a:r>
-          </a:p>
-        </p:txBody>
-      </p:sp>
-      <p:sp>
-        <p:nvSpPr>
-          <p:cNvPr id="13" name="TextBox 12"/>
-          <p:cNvSpPr txBox="1"/>
-          <p:nvPr/>
-        </p:nvSpPr>
-        <p:spPr>
-          <a:xfrm>
-            <a:off x="457200" y="5619750"/>
-            <a:ext cx="3333750" cy="381000"/>
-          </a:xfrm>
-          <a:prstGeom prst="rect">
-            <a:avLst/>
-          </a:prstGeom>
-          <a:noFill/>
-        </p:spPr>
-        <p:txBody>
-          <a:bodyPr wrap="square" anchor="t" lIns="0" rIns="0" tIns="0" bIns="0">
-            <a:spAutoFit/>
-          </a:bodyPr>
-          <a:lstStyle/>
-          <a:p>
-            <a:pPr algn="l">
-              <a:lnSpc>
-                <a:spcPct val="110000"/>
-              </a:lnSpc>
-            </a:pPr>
-            <a:r>
-              <a:rPr sz="1100" b="0" i="1">
-                <a:solidFill>
-                  <a:srgbClr val="C8CDD6"/>
-                </a:solidFill>
-                <a:latin typeface="Arial"/>
-              </a:rPr>
-              <a:t>Moderated by Dr. Geremew &amp; Mr. Abebe Dutoro</a:t>
-            </a:r>
-          </a:p>
-        </p:txBody>
-      </p:sp>
-      <p:sp>
-        <p:nvSpPr>
-          <p:cNvPr id="14" name="TextBox 13"/>
-          <p:cNvSpPr txBox="1"/>
-          <p:nvPr/>
-        </p:nvSpPr>
-        <p:spPr>
-          <a:xfrm>
-            <a:off x="457200" y="9334500"/>
-            <a:ext cx="3429000" cy="209550"/>
-          </a:xfrm>
-          <a:prstGeom prst="rect">
-            <a:avLst/>
-          </a:prstGeom>
-          <a:noFill/>
-        </p:spPr>
-        <p:txBody>
-          <a:bodyPr wrap="square" anchor="t" lIns="0" rIns="0" tIns="0" bIns="0">
-            <a:spAutoFit/>
-          </a:bodyPr>
-          <a:lstStyle/>
-          <a:p>
-            <a:pPr algn="l"/>
-            <a:r>
-              <a:rPr sz="1100" b="1" i="0">
-                <a:solidFill>
-                  <a:srgbClr val="FFFFFF"/>
-                </a:solidFill>
-                <a:latin typeface="Arial"/>
-              </a:rPr>
-              <a:t>⊙  Addis Ababa, Ethiopia</a:t>
-            </a:r>
-          </a:p>
-        </p:txBody>
-      </p:sp>
-      <p:sp>
-        <p:nvSpPr>
-          <p:cNvPr id="15" name="TextBox 14"/>
-          <p:cNvSpPr txBox="1"/>
-          <p:nvPr/>
-        </p:nvSpPr>
-        <p:spPr>
-          <a:xfrm>
-            <a:off x="457200" y="9582150"/>
-            <a:ext cx="3429000" cy="381000"/>
-          </a:xfrm>
-          <a:prstGeom prst="rect">
-            <a:avLst/>
-          </a:prstGeom>
-          <a:noFill/>
-        </p:spPr>
-        <p:txBody>
-          <a:bodyPr wrap="square" anchor="t" lIns="0" rIns="0" tIns="0" bIns="0">
-            <a:spAutoFit/>
-          </a:bodyPr>
-          <a:lstStyle/>
-          <a:p>
-            <a:pPr algn="l"/>
-            <a:r>
-              <a:rPr sz="1000" b="0" i="0">
-                <a:solidFill>
-                  <a:srgbClr val="C8CDD6"/>
-                </a:solidFill>
-                <a:latin typeface="Arial"/>
-              </a:rPr>
-              <a:t>June 23–24, 2026   ·   Addis Ababa</a:t>
-            </a:r>
-          </a:p>
-        </p:txBody>
-      </p:sp>
-      <p:sp>
-        <p:nvSpPr>
-          <p:cNvPr id="16" name="TextBox 15"/>
-          <p:cNvSpPr txBox="1"/>
-          <p:nvPr/>
-        </p:nvSpPr>
-        <p:spPr>
-          <a:xfrm>
-            <a:off x="457200" y="9906000"/>
-            <a:ext cx="3429000" cy="228600"/>
-          </a:xfrm>
-          <a:prstGeom prst="rect">
-            <a:avLst/>
-          </a:prstGeom>
-          <a:noFill/>
-        </p:spPr>
-        <p:txBody>
-          <a:bodyPr wrap="square" anchor="t" lIns="0" rIns="0" tIns="0" bIns="0">
-            <a:spAutoFit/>
-          </a:bodyPr>
-          <a:lstStyle/>
-          <a:p>
-            <a:pPr algn="l">
-              <a:lnSpc>
-                <a:spcPct val="105000"/>
-              </a:lnSpc>
-            </a:pPr>
-            <a:r>
-              <a:rPr sz="950" b="0" i="1">
-                <a:solidFill>
-                  <a:srgbClr val="C8CDD6"/>
-                </a:solidFill>
-                <a:latin typeface="Arial"/>
-              </a:rPr>
-              <a:t>“Innovation is Just an Idea without Commercialization”</a:t>
-            </a:r>
-          </a:p>
-        </p:txBody>
-      </p:sp>
-      <p:sp>
-        <p:nvSpPr>
-          <p:cNvPr id="17" name="TextBox 16"/>
-          <p:cNvSpPr txBox="1"/>
-          <p:nvPr/>
-        </p:nvSpPr>
-        <p:spPr>
-          <a:xfrm>
-            <a:off x="4648200" y="1428750"/>
-            <a:ext cx="5143500" cy="228600"/>
-          </a:xfrm>
-          <a:prstGeom prst="rect">
-            <a:avLst/>
-          </a:prstGeom>
-          <a:noFill/>
-        </p:spPr>
-        <p:txBody>
-          <a:bodyPr wrap="square" anchor="t" lIns="0" rIns="0" tIns="0" bIns="0">
-            <a:spAutoFit/>
-          </a:bodyPr>
-          <a:lstStyle/>
-          <a:p>
-            <a:pPr algn="l"/>
-            <a:r>
-              <a:rPr sz="1200" b="1" i="0">
-                <a:solidFill>
-                  <a:srgbClr val="1B2642"/>
-                </a:solidFill>
-                <a:latin typeface="Arial"/>
-              </a:rPr>
-              <a:t>PLENARY DIGNITARIES</a:t>
-            </a:r>
-          </a:p>
-        </p:txBody>
-      </p:sp>
-      <p:sp>
-        <p:nvSpPr>
-          <p:cNvPr id="18" name="Rectangle 17"/>
-          <p:cNvSpPr/>
-          <p:nvPr/>
-        </p:nvSpPr>
-        <p:spPr>
-          <a:xfrm>
-            <a:off x="4648200" y="1733550"/>
-            <a:ext cx="666750" cy="28575"/>
-          </a:xfrm>
-          <a:prstGeom prst="rect">
-            <a:avLst/>
-          </a:prstGeom>
-          <a:solidFill>
-            <a:srgbClr val="C29A3A"/>
-          </a:solidFill>
-          <a:ln>
-            <a:noFill/>
-          </a:ln>
-          <a:effectLst/>
-        </p:spPr>
-        <p:style>
-          <a:lnRef idx="1">
-            <a:schemeClr val="accent1"/>
-          </a:lnRef>
-          <a:fillRef idx="3">
-            <a:schemeClr val="accent1"/>
-          </a:fillRef>
-          <a:effectRef idx="2">
-            <a:schemeClr val="accent1"/>
-          </a:effectRef>
-          <a:fontRef idx="minor">
-            <a:schemeClr val="lt1"/>
-          </a:fontRef>
-        </p:style>
-        <p:txBody>
-          <a:bodyPr rtlCol="0" anchor="ctr"/>
-          <a:lstStyle/>
-          <a:p>
-            <a:pPr algn="ctr"/>
-          </a:p>
-        </p:txBody>
-      </p:sp>
-      <p:sp>
-        <p:nvSpPr>
-          <p:cNvPr id="19" name="Oval 18"/>
-          <p:cNvSpPr/>
-          <p:nvPr/>
-        </p:nvSpPr>
-        <p:spPr>
-          <a:xfrm>
-            <a:off x="4648200" y="2038350"/>
-            <a:ext cx="742950" cy="742950"/>
-          </a:xfrm>
-          <a:prstGeom prst="ellipse">
-            <a:avLst/>
-          </a:prstGeom>
-          <a:solidFill>
-            <a:srgbClr val="EEF0F3"/>
-          </a:solidFill>
-          <a:ln w="12700">
-            <a:solidFill>
-              <a:srgbClr val="142145"/>
-            </a:solidFill>
-            <a:prstDash val="dash"/>
-          </a:ln>
-          <a:effectLst/>
-        </p:spPr>
-        <p:style>
-          <a:lnRef idx="1">
-            <a:schemeClr val="accent1"/>
-          </a:lnRef>
-          <a:fillRef idx="3">
-            <a:schemeClr val="accent1"/>
-          </a:fillRef>
-          <a:effectRef idx="2">
-            <a:schemeClr val="accent1"/>
-          </a:effectRef>
-          <a:fontRef idx="minor">
-            <a:schemeClr val="lt1"/>
-          </a:fontRef>
-        </p:style>
-        <p:txBody>
-          <a:bodyPr rtlCol="0" anchor="ctr"/>
-          <a:lstStyle/>
-          <a:p>
-            <a:pPr algn="ctr"/>
-          </a:p>
-        </p:txBody>
-      </p:sp>
-      <p:sp>
-        <p:nvSpPr>
-          <p:cNvPr id="20" name="TextBox 19"/>
-          <p:cNvSpPr txBox="1"/>
-          <p:nvPr/>
-        </p:nvSpPr>
-        <p:spPr>
-          <a:xfrm>
-            <a:off x="4648200" y="2038350"/>
-            <a:ext cx="742950" cy="742950"/>
+            <a:off x="381000" y="9334500"/>
+            <a:ext cx="3429000" cy="952500"/>
           </a:xfrm>
           <a:prstGeom prst="rect">
             <a:avLst/>
@@ -5084,131 +5665,41 @@
           </a:bodyPr>
           <a:lstStyle/>
           <a:p>
-            <a:pPr algn="ctr"/>
-            <a:r>
-              <a:rPr sz="1000" b="0" i="0">
-                <a:solidFill>
-                  <a:srgbClr val="6B7280"/>
-                </a:solidFill>
-                <a:latin typeface="Arial"/>
-              </a:rPr>
-              <a:t>PHOTO</a:t>
-            </a:r>
-          </a:p>
-        </p:txBody>
-      </p:sp>
-      <p:sp>
-        <p:nvSpPr>
-          <p:cNvPr id="21" name="TextBox 20"/>
+            <a:pPr algn="l"/>
+            <a:r>
+              <a:rPr sz="1300" b="1" i="0">
+                <a:solidFill>
+                  <a:srgbClr val="FFFFFF"/>
+                </a:solidFill>
+                <a:latin typeface="Arial"/>
+              </a:rPr>
+              <a:t>⊙  Addis Ababa, Ethiopia</a:t>
+            </a:r>
+          </a:p>
+          <a:p>
+            <a:pPr algn="l"/>
+            <a:r>
+              <a:rPr sz="1100" b="0" i="0">
+                <a:solidFill>
+                  <a:srgbClr val="F2F3F5"/>
+                </a:solidFill>
+                <a:latin typeface="Arial"/>
+              </a:rPr>
+              <a:t>June 23–24, 2026</a:t>
+            </a:r>
+          </a:p>
+        </p:txBody>
+      </p:sp>
+      <p:sp>
+        <p:nvSpPr>
+          <p:cNvPr id="33" name="TextBox 32"/>
           <p:cNvSpPr txBox="1"/>
           <p:nvPr/>
         </p:nvSpPr>
         <p:spPr>
           <a:xfrm>
-            <a:off x="5600700" y="2200275"/>
-            <a:ext cx="4953000" cy="457200"/>
-          </a:xfrm>
-          <a:prstGeom prst="rect">
-            <a:avLst/>
-          </a:prstGeom>
-          <a:noFill/>
-        </p:spPr>
-        <p:txBody>
-          <a:bodyPr wrap="square" anchor="t" lIns="0" rIns="0" tIns="0" bIns="0">
-            <a:spAutoFit/>
-          </a:bodyPr>
-          <a:lstStyle/>
-          <a:p>
-            <a:pPr algn="l">
-              <a:lnSpc>
-                <a:spcPct val="110000"/>
-              </a:lnSpc>
-            </a:pPr>
-            <a:r>
-              <a:rPr sz="1350" b="1" i="0">
-                <a:solidFill>
-                  <a:srgbClr val="1B2642"/>
-                </a:solidFill>
-                <a:latin typeface="Arial"/>
-              </a:rPr>
-              <a:t>H.E. Muferiat Kamil</a:t>
-            </a:r>
-          </a:p>
-          <a:p>
-            <a:pPr algn="l">
-              <a:lnSpc>
-                <a:spcPct val="110000"/>
-              </a:lnSpc>
-            </a:pPr>
-            <a:r>
-              <a:rPr sz="1100" b="0" i="0">
-                <a:solidFill>
-                  <a:srgbClr val="C29A3A"/>
-                </a:solidFill>
-                <a:latin typeface="Arial"/>
-              </a:rPr>
-              <a:t>Minister, MInT</a:t>
-            </a:r>
-          </a:p>
-        </p:txBody>
-      </p:sp>
-      <p:sp>
-        <p:nvSpPr>
-          <p:cNvPr id="22" name="Oval 21"/>
-          <p:cNvSpPr/>
-          <p:nvPr/>
-        </p:nvSpPr>
-        <p:spPr>
-          <a:xfrm>
-            <a:off x="4648200" y="3467100"/>
-            <a:ext cx="742950" cy="742950"/>
-          </a:xfrm>
-          <a:prstGeom prst="ellipse">
-            <a:avLst/>
-          </a:prstGeom>
-          <a:solidFill>
-            <a:srgbClr val="EEF0F3"/>
-          </a:solidFill>
-          <a:ln w="12700">
-            <a:solidFill>
-              <a:srgbClr val="142145"/>
-            </a:solidFill>
-            <a:prstDash val="dash"/>
-          </a:ln>
-          <a:effectLst/>
-        </p:spPr>
-        <p:style>
-          <a:lnRef idx="1">
-            <a:schemeClr val="accent1"/>
-          </a:lnRef>
-          <a:fillRef idx="3">
-            <a:schemeClr val="accent1"/>
-          </a:fillRef>
-          <a:effectRef idx="2">
-            <a:schemeClr val="accent1"/>
-          </a:effectRef>
-          <a:fontRef idx="minor">
-            <a:schemeClr val="lt1"/>
-          </a:fontRef>
-        </p:style>
-        <p:txBody>
-          <a:bodyPr rtlCol="0" anchor="ctr"/>
-          <a:lstStyle/>
-          <a:p>
-            <a:pPr algn="ctr"/>
-          </a:p>
-        </p:txBody>
-      </p:sp>
-      <p:sp>
-        <p:nvSpPr>
-          <p:cNvPr id="23" name="TextBox 22"/>
-          <p:cNvSpPr txBox="1"/>
-          <p:nvPr/>
-        </p:nvSpPr>
-        <p:spPr>
-          <a:xfrm>
-            <a:off x="4648200" y="3467100"/>
-            <a:ext cx="742950" cy="742950"/>
+            <a:off x="5143500" y="9334500"/>
+            <a:ext cx="4762500" cy="952500"/>
           </a:xfrm>
           <a:prstGeom prst="rect">
             <a:avLst/>
@@ -5221,344 +5712,15 @@
           </a:bodyPr>
           <a:lstStyle/>
           <a:p>
-            <a:pPr algn="ctr"/>
-            <a:r>
-              <a:rPr sz="1000" b="0" i="0">
-                <a:solidFill>
-                  <a:srgbClr val="6B7280"/>
-                </a:solidFill>
-                <a:latin typeface="Arial"/>
-              </a:rPr>
-              <a:t>PHOTO</a:t>
-            </a:r>
-          </a:p>
-        </p:txBody>
-      </p:sp>
-      <p:sp>
-        <p:nvSpPr>
-          <p:cNvPr id="24" name="TextBox 23"/>
-          <p:cNvSpPr txBox="1"/>
-          <p:nvPr/>
-        </p:nvSpPr>
-        <p:spPr>
-          <a:xfrm>
-            <a:off x="5600700" y="3629025"/>
-            <a:ext cx="4953000" cy="457200"/>
-          </a:xfrm>
-          <a:prstGeom prst="rect">
-            <a:avLst/>
-          </a:prstGeom>
-          <a:noFill/>
-        </p:spPr>
-        <p:txBody>
-          <a:bodyPr wrap="square" anchor="t" lIns="0" rIns="0" tIns="0" bIns="0">
-            <a:spAutoFit/>
-          </a:bodyPr>
-          <a:lstStyle/>
-          <a:p>
-            <a:pPr algn="l">
-              <a:lnSpc>
-                <a:spcPct val="110000"/>
-              </a:lnSpc>
-            </a:pPr>
-            <a:r>
-              <a:rPr sz="1350" b="1" i="0">
-                <a:solidFill>
-                  <a:srgbClr val="1B2642"/>
-                </a:solidFill>
-                <a:latin typeface="Arial"/>
-              </a:rPr>
-              <a:t>H.E. Belete Molla</a:t>
-            </a:r>
-          </a:p>
-          <a:p>
-            <a:pPr algn="l">
-              <a:lnSpc>
-                <a:spcPct val="110000"/>
-              </a:lnSpc>
-            </a:pPr>
-            <a:r>
-              <a:rPr sz="1100" b="0" i="0">
-                <a:solidFill>
-                  <a:srgbClr val="C29A3A"/>
-                </a:solidFill>
-                <a:latin typeface="Arial"/>
-              </a:rPr>
-              <a:t>Minister of Industry</a:t>
-            </a:r>
-          </a:p>
-        </p:txBody>
-      </p:sp>
-      <p:sp>
-        <p:nvSpPr>
-          <p:cNvPr id="25" name="Oval 24"/>
-          <p:cNvSpPr/>
-          <p:nvPr/>
-        </p:nvSpPr>
-        <p:spPr>
-          <a:xfrm>
-            <a:off x="4648200" y="4895850"/>
-            <a:ext cx="742950" cy="742950"/>
-          </a:xfrm>
-          <a:prstGeom prst="ellipse">
-            <a:avLst/>
-          </a:prstGeom>
-          <a:solidFill>
-            <a:srgbClr val="EEF0F3"/>
-          </a:solidFill>
-          <a:ln w="12700">
-            <a:solidFill>
-              <a:srgbClr val="142145"/>
-            </a:solidFill>
-            <a:prstDash val="dash"/>
-          </a:ln>
-          <a:effectLst/>
-        </p:spPr>
-        <p:style>
-          <a:lnRef idx="1">
-            <a:schemeClr val="accent1"/>
-          </a:lnRef>
-          <a:fillRef idx="3">
-            <a:schemeClr val="accent1"/>
-          </a:fillRef>
-          <a:effectRef idx="2">
-            <a:schemeClr val="accent1"/>
-          </a:effectRef>
-          <a:fontRef idx="minor">
-            <a:schemeClr val="lt1"/>
-          </a:fontRef>
-        </p:style>
-        <p:txBody>
-          <a:bodyPr rtlCol="0" anchor="ctr"/>
-          <a:lstStyle/>
-          <a:p>
-            <a:pPr algn="ctr"/>
-          </a:p>
-        </p:txBody>
-      </p:sp>
-      <p:sp>
-        <p:nvSpPr>
-          <p:cNvPr id="26" name="TextBox 25"/>
-          <p:cNvSpPr txBox="1"/>
-          <p:nvPr/>
-        </p:nvSpPr>
-        <p:spPr>
-          <a:xfrm>
-            <a:off x="4648200" y="4895850"/>
-            <a:ext cx="742950" cy="742950"/>
-          </a:xfrm>
-          <a:prstGeom prst="rect">
-            <a:avLst/>
-          </a:prstGeom>
-          <a:noFill/>
-        </p:spPr>
-        <p:txBody>
-          <a:bodyPr wrap="square" anchor="ctr" lIns="0" rIns="0" tIns="0" bIns="0">
-            <a:spAutoFit/>
-          </a:bodyPr>
-          <a:lstStyle/>
-          <a:p>
-            <a:pPr algn="ctr"/>
-            <a:r>
-              <a:rPr sz="1000" b="0" i="0">
-                <a:solidFill>
-                  <a:srgbClr val="6B7280"/>
-                </a:solidFill>
-                <a:latin typeface="Arial"/>
-              </a:rPr>
-              <a:t>PHOTO</a:t>
-            </a:r>
-          </a:p>
-        </p:txBody>
-      </p:sp>
-      <p:sp>
-        <p:nvSpPr>
-          <p:cNvPr id="27" name="TextBox 26"/>
-          <p:cNvSpPr txBox="1"/>
-          <p:nvPr/>
-        </p:nvSpPr>
-        <p:spPr>
-          <a:xfrm>
-            <a:off x="5600700" y="5057775"/>
-            <a:ext cx="4953000" cy="457200"/>
-          </a:xfrm>
-          <a:prstGeom prst="rect">
-            <a:avLst/>
-          </a:prstGeom>
-          <a:noFill/>
-        </p:spPr>
-        <p:txBody>
-          <a:bodyPr wrap="square" anchor="t" lIns="0" rIns="0" tIns="0" bIns="0">
-            <a:spAutoFit/>
-          </a:bodyPr>
-          <a:lstStyle/>
-          <a:p>
-            <a:pPr algn="l">
-              <a:lnSpc>
-                <a:spcPct val="110000"/>
-              </a:lnSpc>
-            </a:pPr>
-            <a:r>
-              <a:rPr sz="1350" b="1" i="0">
-                <a:solidFill>
-                  <a:srgbClr val="1B2642"/>
-                </a:solidFill>
-                <a:latin typeface="Arial"/>
-              </a:rPr>
-              <a:t>Dr. Abreham Debebe</a:t>
-            </a:r>
-          </a:p>
-          <a:p>
-            <a:pPr algn="l">
-              <a:lnSpc>
-                <a:spcPct val="110000"/>
-              </a:lnSpc>
-            </a:pPr>
-            <a:r>
-              <a:rPr sz="1100" b="0" i="0">
-                <a:solidFill>
-                  <a:srgbClr val="C29A3A"/>
-                </a:solidFill>
-                <a:latin typeface="Arial"/>
-              </a:rPr>
-              <a:t>AASTU</a:t>
-            </a:r>
-          </a:p>
-        </p:txBody>
-      </p:sp>
-      <p:sp>
-        <p:nvSpPr>
-          <p:cNvPr id="28" name="Oval 27"/>
-          <p:cNvSpPr/>
-          <p:nvPr/>
-        </p:nvSpPr>
-        <p:spPr>
-          <a:xfrm>
-            <a:off x="4648200" y="6324600"/>
-            <a:ext cx="742950" cy="742950"/>
-          </a:xfrm>
-          <a:prstGeom prst="ellipse">
-            <a:avLst/>
-          </a:prstGeom>
-          <a:solidFill>
-            <a:srgbClr val="EEF0F3"/>
-          </a:solidFill>
-          <a:ln w="12700">
-            <a:solidFill>
-              <a:srgbClr val="142145"/>
-            </a:solidFill>
-            <a:prstDash val="dash"/>
-          </a:ln>
-          <a:effectLst/>
-        </p:spPr>
-        <p:style>
-          <a:lnRef idx="1">
-            <a:schemeClr val="accent1"/>
-          </a:lnRef>
-          <a:fillRef idx="3">
-            <a:schemeClr val="accent1"/>
-          </a:fillRef>
-          <a:effectRef idx="2">
-            <a:schemeClr val="accent1"/>
-          </a:effectRef>
-          <a:fontRef idx="minor">
-            <a:schemeClr val="lt1"/>
-          </a:fontRef>
-        </p:style>
-        <p:txBody>
-          <a:bodyPr rtlCol="0" anchor="ctr"/>
-          <a:lstStyle/>
-          <a:p>
-            <a:pPr algn="ctr"/>
-          </a:p>
-        </p:txBody>
-      </p:sp>
-      <p:sp>
-        <p:nvSpPr>
-          <p:cNvPr id="29" name="TextBox 28"/>
-          <p:cNvSpPr txBox="1"/>
-          <p:nvPr/>
-        </p:nvSpPr>
-        <p:spPr>
-          <a:xfrm>
-            <a:off x="4648200" y="6324600"/>
-            <a:ext cx="742950" cy="742950"/>
-          </a:xfrm>
-          <a:prstGeom prst="rect">
-            <a:avLst/>
-          </a:prstGeom>
-          <a:noFill/>
-        </p:spPr>
-        <p:txBody>
-          <a:bodyPr wrap="square" anchor="ctr" lIns="0" rIns="0" tIns="0" bIns="0">
-            <a:spAutoFit/>
-          </a:bodyPr>
-          <a:lstStyle/>
-          <a:p>
-            <a:pPr algn="ctr"/>
-            <a:r>
-              <a:rPr sz="1000" b="0" i="0">
-                <a:solidFill>
-                  <a:srgbClr val="6B7280"/>
-                </a:solidFill>
-                <a:latin typeface="Arial"/>
-              </a:rPr>
-              <a:t>PHOTO</a:t>
-            </a:r>
-          </a:p>
-        </p:txBody>
-      </p:sp>
-      <p:sp>
-        <p:nvSpPr>
-          <p:cNvPr id="30" name="TextBox 29"/>
-          <p:cNvSpPr txBox="1"/>
-          <p:nvPr/>
-        </p:nvSpPr>
-        <p:spPr>
-          <a:xfrm>
-            <a:off x="5600700" y="6486525"/>
-            <a:ext cx="4953000" cy="457200"/>
-          </a:xfrm>
-          <a:prstGeom prst="rect">
-            <a:avLst/>
-          </a:prstGeom>
-          <a:noFill/>
-        </p:spPr>
-        <p:txBody>
-          <a:bodyPr wrap="square" anchor="t" lIns="0" rIns="0" tIns="0" bIns="0">
-            <a:spAutoFit/>
-          </a:bodyPr>
-          <a:lstStyle/>
-          <a:p>
-            <a:pPr algn="l">
-              <a:lnSpc>
-                <a:spcPct val="110000"/>
-              </a:lnSpc>
-            </a:pPr>
-            <a:r>
-              <a:rPr sz="1350" b="1" i="0">
-                <a:solidFill>
-                  <a:srgbClr val="1B2642"/>
-                </a:solidFill>
-                <a:latin typeface="Arial"/>
-              </a:rPr>
-              <a:t>Dr. Dereje Engida</a:t>
-            </a:r>
-          </a:p>
-          <a:p>
-            <a:pPr algn="l">
-              <a:lnSpc>
-                <a:spcPct val="110000"/>
-              </a:lnSpc>
-            </a:pPr>
-            <a:r>
-              <a:rPr sz="1100" b="0" i="0">
-                <a:solidFill>
-                  <a:srgbClr val="C29A3A"/>
-                </a:solidFill>
-                <a:latin typeface="Arial"/>
-              </a:rPr>
-              <a:t>EDI</a:t>
+            <a:pPr algn="r"/>
+            <a:r>
+              <a:rPr sz="1250" b="0" i="1">
+                <a:solidFill>
+                  <a:srgbClr val="A6852E"/>
+                </a:solidFill>
+                <a:latin typeface="Arial"/>
+              </a:rPr>
+              <a:t>“Innovation Without Commercialization is Just an Idea”</a:t>
             </a:r>
           </a:p>
         </p:txBody>

</xml_diff>